<commit_message>
Label the 80,000-camera tier split as a planning assumption
The brief gives only the ~80,000 total; the 12/28/35/25% split behind the
GPU count and server cost is our estimate from how departments use cameras.
The tiering slide and the scale plan now say so, and the prep doc carries
the answer if a juror asks. Also brings the prep doc's design-dimension,
scale and evaluation-area slide numbers in line with the team slide.

Co-authored-by: Copilot <223556219+Copilot@users.noreply.github.com>
</commit_message>
<xml_diff>
--- a/docs/Sentinel-Finale-Pitch.pptx
+++ b/docs/Sentinel-Finale-Pitch.pptx
@@ -1683,7 +1683,7 @@
           <a:p>
             <a:r>
               <a:rPr lang="en-US" dirty="0"/>
-              <a:t>A highway check-post and a ration-shop godown are different jobs. About one camera in eight reads plates continuously; a quarter are view-only. The tier is a setting each department controls and can change live — a camera goes to continuous for a bandobast and back afterwards. That is what makes eighty thousand cameras tractable.</a:t>
+              <a:t>A highway check-post and a ration-shop godown are different jobs. About one camera in eight reads plates continuously; a quarter are view-only. The tier is a setting each department controls and can change live — a camera goes to continuous for a bandobast and back afterwards. That is what makes eighty thousand cameras tractable. Be clear that the split is our planning assumption: the brief gives the eighty thousand total and how departments use their cameras, not a breakdown. The GPU count and the server cost follow from it, and each department’s inventory replaces it in the pilot.</a:t>
             </a:r>
             <a:endParaRPr lang="en-US" dirty="0"/>
           </a:p>
@@ -11666,6 +11666,45 @@
           </a:p>
         </p:txBody>
       </p:sp>
+      <p:sp>
+        <p:nvSpPr>
+          <p:cNvPr id="33" name="Text 28"/>
+          <p:cNvSpPr/>
+          <p:nvPr/>
+        </p:nvSpPr>
+        <p:spPr>
+          <a:xfrm>
+            <a:off x="548640" y="6172200"/>
+            <a:ext cx="10362895" cy="411480"/>
+          </a:xfrm>
+          <a:prstGeom prst="rect">
+            <a:avLst/>
+          </a:prstGeom>
+          <a:noFill/>
+          <a:ln/>
+        </p:spPr>
+        <p:txBody>
+          <a:bodyPr wrap="square" lIns="0" tIns="0" rIns="0" bIns="0" rtlCol="0" anchor="t"/>
+          <a:lstStyle/>
+          <a:p>
+            <a:pPr indent="0" marL="0">
+              <a:buNone/>
+            </a:pPr>
+            <a:r>
+              <a:rPr lang="en-US" sz="1000" i="1" dirty="0">
+                <a:solidFill>
+                  <a:srgbClr val="536079"/>
+                </a:solidFill>
+                <a:latin typeface="Calibri" pitchFamily="34" charset="0"/>
+                <a:ea typeface="Calibri" pitchFamily="34" charset="-122"/>
+                <a:cs typeface="Calibri" pitchFamily="34" charset="-120"/>
+              </a:rPr>
+              <a:t>Planning assumption, not a survey: the ~80,000 total is from the brief; the split is our estimate from how departments use their cameras. Compute and cost are sized from it; department inventories replace it in the pilot.</a:t>
+            </a:r>
+            <a:endParaRPr lang="en-US" sz="1000" dirty="0"/>
+          </a:p>
+        </p:txBody>
+      </p:sp>
     </p:spTree>
   </p:cSld>
   <p:clrMapOvr>

</xml_diff>

<commit_message>
Recapture the pitch deck and README from the gate-board console
Both screenshot sets showed the console before the redesign. Recaptured
on the mirror after a clean reset, and the deck's crop windows retuned
to the new layout so no panel is cut mid-word.

GJ39C8018 was the deck's timed example, but the new clock reader cannot
confirm its frame: the recording freezes there (one clock second on
frames 3.8 s apart). GJ11S7924 at Timbavadi Gate, 17 Jun 2026 18:01:21,
is the timed example now, matching the time printed on its snapshot.
Showcase prep's mirror fallback notes are updated to the new reader's
results, and the Trust slide's notes name the Verify integrity button.

Co-authored-by: Copilot <223556219+Copilot@users.noreply.github.com>
</commit_message>
<xml_diff>
--- a/docs/Sentinel-Finale-Pitch.pptx
+++ b/docs/Sentinel-Finale-Pitch.pptx
@@ -2651,7 +2651,7 @@
           <a:p>
             <a:r>
               <a:rPr lang="en-US" dirty="0"/>
-              <a:t>This is the slide for both halves of the room. For the officers: the time in the report is the time printed on the camera’s own frame, and if it cannot be read we say “time unknown” rather than guess — a record that holds up under cross-examination. Every search, export and reveal is logged in a hash chain; change one entry and verification fails. For the professors: the clock reading is accepted only when a second reading agrees, and exports carry a SHA-256 manifest. And we do no face recognition at all — faces are detected only to be blurred. If time allows, show Admin, then Audit, then Verify chain.</a:t>
+              <a:t>This is the slide for both halves of the room. For the officers: the time in the report is the time printed on the camera’s own frame, and if it cannot be read we say “time unknown” rather than guess — a record that holds up under cross-examination. Every search, export and reveal is logged in a hash chain; change one entry and verification fails. For the professors: the clock reading is accepted only when a second reading agrees, and exports carry a SHA-256 manifest. And we do no face recognition at all — faces are detected only to be blurred. If time allows, show Admin, then Audit, then Verify integrity.</a:t>
             </a:r>
             <a:endParaRPr lang="en-US" dirty="0"/>
           </a:p>
@@ -3321,12 +3321,12 @@
         </p:nvSpPr>
         <p:spPr>
           <a:xfrm>
-            <a:off x="6473952" y="1946770"/>
-            <a:ext cx="5385816" cy="2964461"/>
+            <a:off x="6473952" y="2080117"/>
+            <a:ext cx="5385816" cy="2697766"/>
           </a:xfrm>
           <a:prstGeom prst="roundRect">
             <a:avLst>
-              <a:gd name="adj" fmla="val 3085"/>
+              <a:gd name="adj" fmla="val 3389"/>
             </a:avLst>
           </a:prstGeom>
           <a:solidFill>
@@ -3363,8 +3363,8 @@
         </p:blipFill>
         <p:spPr>
           <a:xfrm>
-            <a:off x="6537960" y="2010778"/>
-            <a:ext cx="5257800" cy="2836445"/>
+            <a:off x="6537960" y="2144125"/>
+            <a:ext cx="5257800" cy="2569750"/>
           </a:xfrm>
           <a:prstGeom prst="rect">
             <a:avLst/>
@@ -3379,7 +3379,7 @@
         </p:nvSpPr>
         <p:spPr>
           <a:xfrm>
-            <a:off x="5897880" y="1645018"/>
+            <a:off x="5897880" y="1778365"/>
             <a:ext cx="2834640" cy="566928"/>
           </a:xfrm>
           <a:prstGeom prst="roundRect">
@@ -3413,7 +3413,7 @@
         </p:nvSpPr>
         <p:spPr>
           <a:xfrm>
-            <a:off x="6025896" y="1754746"/>
+            <a:off x="6025896" y="1888093"/>
             <a:ext cx="347472" cy="347472"/>
           </a:xfrm>
           <a:prstGeom prst="ellipse">
@@ -3446,7 +3446,7 @@
         </p:blipFill>
         <p:spPr>
           <a:xfrm>
-            <a:off x="6105815" y="1834664"/>
+            <a:off x="6105815" y="1968012"/>
             <a:ext cx="187635" cy="187635"/>
           </a:xfrm>
           <a:prstGeom prst="rect">
@@ -3462,7 +3462,7 @@
         </p:nvSpPr>
         <p:spPr>
           <a:xfrm>
-            <a:off x="6464808" y="1754746"/>
+            <a:off x="6464808" y="1888093"/>
             <a:ext cx="2176272" cy="347472"/>
           </a:xfrm>
           <a:prstGeom prst="rect">
@@ -3501,7 +3501,7 @@
         </p:nvSpPr>
         <p:spPr>
           <a:xfrm>
-            <a:off x="9128455" y="4618622"/>
+            <a:off x="9128455" y="4485275"/>
             <a:ext cx="2560320" cy="566928"/>
           </a:xfrm>
           <a:prstGeom prst="roundRect">
@@ -3535,7 +3535,7 @@
         </p:nvSpPr>
         <p:spPr>
           <a:xfrm>
-            <a:off x="9256471" y="4728350"/>
+            <a:off x="9256471" y="4595003"/>
             <a:ext cx="347472" cy="347472"/>
           </a:xfrm>
           <a:prstGeom prst="ellipse">
@@ -3568,7 +3568,7 @@
         </p:blipFill>
         <p:spPr>
           <a:xfrm>
-            <a:off x="9336390" y="4808269"/>
+            <a:off x="9336390" y="4674921"/>
             <a:ext cx="187635" cy="187635"/>
           </a:xfrm>
           <a:prstGeom prst="rect">
@@ -3584,7 +3584,7 @@
         </p:nvSpPr>
         <p:spPr>
           <a:xfrm>
-            <a:off x="9695383" y="4728350"/>
+            <a:off x="9695383" y="4595003"/>
             <a:ext cx="1901952" cy="347472"/>
           </a:xfrm>
           <a:prstGeom prst="rect">
@@ -10679,11 +10679,11 @@
         <p:spPr>
           <a:xfrm>
             <a:off x="548640" y="1673352"/>
-            <a:ext cx="6437376" cy="3892424"/>
+            <a:ext cx="6437376" cy="3593721"/>
           </a:xfrm>
           <a:prstGeom prst="roundRect">
             <a:avLst>
-              <a:gd name="adj" fmla="val 2349"/>
+              <a:gd name="adj" fmla="val 2544"/>
             </a:avLst>
           </a:prstGeom>
           <a:solidFill>
@@ -10721,7 +10721,7 @@
         <p:spPr>
           <a:xfrm>
             <a:off x="612648" y="1737360"/>
-            <a:ext cx="6309360" cy="3764408"/>
+            <a:ext cx="6309360" cy="3465705"/>
           </a:xfrm>
           <a:prstGeom prst="rect">
             <a:avLst/>
@@ -11433,11 +11433,11 @@
         <p:spPr>
           <a:xfrm>
             <a:off x="548640" y="1581912"/>
-            <a:ext cx="6986016" cy="3827727"/>
+            <a:ext cx="6986016" cy="3479864"/>
           </a:xfrm>
           <a:prstGeom prst="roundRect">
             <a:avLst>
-              <a:gd name="adj" fmla="val 2389"/>
+              <a:gd name="adj" fmla="val 2628"/>
             </a:avLst>
           </a:prstGeom>
           <a:solidFill>
@@ -11475,7 +11475,7 @@
         <p:spPr>
           <a:xfrm>
             <a:off x="612648" y="1645920"/>
-            <a:ext cx="6858000" cy="3699711"/>
+            <a:ext cx="6858000" cy="3351848"/>
           </a:xfrm>
           <a:prstGeom prst="rect">
             <a:avLst/>
@@ -11871,7 +11871,7 @@
         </p:nvSpPr>
         <p:spPr>
           <a:xfrm>
-            <a:off x="548640" y="5546799"/>
+            <a:off x="548640" y="5198936"/>
             <a:ext cx="6949440" cy="411480"/>
           </a:xfrm>
           <a:prstGeom prst="rect">
@@ -11896,7 +11896,7 @@
                 <a:ea typeface="Calibri" pitchFamily="34" charset="-122"/>
                 <a:cs typeface="Calibri" pitchFamily="34" charset="-120"/>
               </a:rPr>
-              <a:t>The real console on recorded government footage: GJ39C8018 at Gandhidham, 8 Aug 2026, 21:10 — the time printed on the frame.</a:t>
+              <a:t>The real console on recorded government footage: GJ11S7924 at Timbavadi Gate, Junagadh, 17 Jun 2026, 18:01 — the time printed on the frame.</a:t>
             </a:r>
             <a:endParaRPr lang="en-US" sz="1100" dirty="0"/>
           </a:p>
@@ -12099,11 +12099,11 @@
         <p:spPr>
           <a:xfrm>
             <a:off x="548640" y="1627632"/>
-            <a:ext cx="5248656" cy="3627314"/>
+            <a:ext cx="5248656" cy="3639312"/>
           </a:xfrm>
           <a:prstGeom prst="roundRect">
             <a:avLst>
-              <a:gd name="adj" fmla="val 2521"/>
+              <a:gd name="adj" fmla="val 2513"/>
             </a:avLst>
           </a:prstGeom>
           <a:solidFill>
@@ -12141,7 +12141,7 @@
         <p:spPr>
           <a:xfrm>
             <a:off x="612648" y="1691640"/>
-            <a:ext cx="5120640" cy="3499298"/>
+            <a:ext cx="5120640" cy="3511296"/>
           </a:xfrm>
           <a:prstGeom prst="rect">
             <a:avLst/>
@@ -24252,11 +24252,11 @@
         <p:spPr>
           <a:xfrm>
             <a:off x="6839712" y="1673352"/>
-            <a:ext cx="4821631" cy="3318447"/>
+            <a:ext cx="4821631" cy="2852242"/>
           </a:xfrm>
           <a:prstGeom prst="roundRect">
             <a:avLst>
-              <a:gd name="adj" fmla="val 2756"/>
+              <a:gd name="adj" fmla="val 3206"/>
             </a:avLst>
           </a:prstGeom>
           <a:solidFill>
@@ -24294,7 +24294,7 @@
         <p:spPr>
           <a:xfrm>
             <a:off x="6903720" y="1737360"/>
-            <a:ext cx="4693615" cy="3190431"/>
+            <a:ext cx="4693615" cy="2724226"/>
           </a:xfrm>
           <a:prstGeom prst="rect">
             <a:avLst/>

</xml_diff>

<commit_message>
Re-measure plate accuracy: 80.5% after the vote, not 78%
The same 81 hand-labelled crops, read again with the code at aec10b7.
The OCR's raw reads are identical; that commit's plate-format change
stopped three damaged reads being "corrected" into the wrong layout, so
character accuracy rises from 88.0% to 88.6% and the vote gains one
vehicle (33 of 41, from 32). Still below the 85% gate.

The evidence report keeps both runs side by side and says why the new
CSV's latencies are higher (a worker was running). README, the ANPR and
traceability docs, showcase prep and the pitch deck now cite 80.5%; the
pitch notes add that RapidOCR reads the camera clock, not plates. The
submission deck is left as submitted.

Co-authored-by: Copilot <223556219+Copilot@users.noreply.github.com>
</commit_message>
<xml_diff>
--- a/docs/Sentinel-Finale-Pitch.pptx
+++ b/docs/Sentinel-Finale-Pitch.pptx
@@ -1255,8 +1255,8 @@
             <a:r>
               <a:rPr lang="en-US" dirty="0"/>
               <a:t>[11:00–12:30] Say “we measured that” for each row, and read the right-hand panel aloud — the professors will respect it, and the officers will trust the rest more for it.
-Plate accuracy: 78% of 41 vehicles read exactly, on hand-labelled government footage; it started at 8.6% and the measurement drove the fixes. Clock reading: 97.7% exact on 87 frames with a legible clock, with no wrong times. Capacity: on one base M2 laptop, four cameras analysed at 4 frames a second kept up; eight cameras’ worth did not. Latency: median 27–40 s from the moment in the footage to the stored sighting, p90 67–87 s, across two evidence runs — mostly the multi-frame vote, bought on purpose. DR: a million detections restored in 5.7 s, and a tampered audit row caught. 698 backend and 65 browser tests.
-If asked “why 78%?”: the cameras are wide-angle; half of all plate crops were unreadable even to a person. Fine-tuning on Gujarat plates and choosing cameras by plate yield are the pilot’s first work items.</a:t>
+Plate accuracy: 80.5% of 41 vehicles (33) read exactly, re-measured 12 October, on hand-labelled government footage; it started at 8.6% and the measurement drove the fixes. Clock reading: 97.7% exact on 87 frames with a legible clock, with no wrong times. Capacity: on one base M2 laptop, four cameras analysed at 4 frames a second kept up; eight cameras’ worth did not. Latency: median 27–40 s from the moment in the footage to the stored sighting, p90 67–87 s, across two evidence runs — mostly the multi-frame vote, bought on purpose. DR: a million detections restored in 5.7 s, and a tampered audit row caught. 698 backend and 65 browser tests.
+If asked “why 80.5%?”: the cameras are wide-angle; half of all plate crops were unreadable even to a person. Fine-tuning on Gujarat plates and choosing cameras by plate yield are the pilot’s first work items.</a:t>
             </a:r>
             <a:endParaRPr lang="en-US" dirty="0"/>
           </a:p>
@@ -2955,7 +2955,7 @@
               <a:rPr lang="en-US" dirty="0"/>
               <a:t>Backup for live step 2, and the slide for the professors. One real frame from the government grid, the four things the edge does to it.
 1 Detect and track the vehicle (YOLO11n, a Kalman tracker stepped by the video’s own timestamps, not arrival time). 2 Find the plate (YOLOv9-t) and read it (CCT-XS OCR) on several frames, then vote: a plate is committed only when the frames agree and it fits the Indian registration grammar. 3 Read the date and time burned into the frame (PP-OCRv6), accepted only when a second reading agrees. 4 Store one sighting: camera, printed time, plate, frame.
-The numbers are measured on hand-labelled government footage, blind to the OCR’s output. Say the accuracy plainly: 78% of vehicles read exactly after the vote — below our own 85% target. It was 8.6% before we measured; the measurement drove the fixes. Half the plate crops on these wide-angle cameras were unreadable even to a person; no model reads a 20-pixel plate. On-site, that is why we pick cameras by plate yield.
+The numbers are measured on hand-labelled government footage, blind to the OCR’s output. Say the accuracy plainly: 80.5% of vehicles (33 of 41) read exactly after the vote — below our own 85% target. It was 8.6% before we measured; the measurement drove the fixes. If asked about RapidOCR: that reads the camera’s clock (the 97.7%), not plates. Half the plate crops on these wide-angle cameras were unreadable even to a person; no model reads a 20-pixel plate. On-site, that is why we pick cameras by plate yield.
 All five models run on ONNX Runtime on this laptop’s CPU, with no internet.</a:t>
             </a:r>
             <a:endParaRPr lang="en-US" dirty="0"/>
@@ -5934,7 +5934,7 @@
                 <a:ea typeface="Franklin Gothic Demi Cond" pitchFamily="34" charset="-122"/>
                 <a:cs typeface="Franklin Gothic Demi Cond" pitchFamily="34" charset="-120"/>
               </a:rPr>
-              <a:t>78%</a:t>
+              <a:t>80.5%</a:t>
             </a:r>
             <a:endParaRPr lang="en-US" sz="2400" dirty="0"/>
           </a:p>
@@ -5973,7 +5973,7 @@
                 <a:ea typeface="Franklin Gothic Book" pitchFamily="34" charset="-122"/>
                 <a:cs typeface="Franklin Gothic Book" pitchFamily="34" charset="-120"/>
               </a:rPr>
-              <a:t>41 vehicles, hand-labelled government footage, after the vote</a:t>
+              <a:t>33 of 41 vehicles, hand-labelled government footage, after the vote</a:t>
             </a:r>
             <a:endParaRPr lang="en-US" sz="1200" dirty="0"/>
           </a:p>
@@ -28550,7 +28550,7 @@
                 <a:ea typeface="Franklin Gothic Demi Cond" pitchFamily="34" charset="-122"/>
                 <a:cs typeface="Franklin Gothic Demi Cond" pitchFamily="34" charset="-120"/>
               </a:rPr>
-              <a:t>78%</a:t>
+              <a:t>80.5%</a:t>
             </a:r>
             <a:endParaRPr lang="en-US" sz="4000" dirty="0"/>
           </a:p>
@@ -28628,7 +28628,7 @@
                 <a:ea typeface="Franklin Gothic Book" pitchFamily="34" charset="-122"/>
                 <a:cs typeface="Franklin Gothic Book" pitchFamily="34" charset="-120"/>
               </a:rPr>
-              <a:t>41 vehicles, after the vote</a:t>
+              <a:t>33 of 41 vehicles, after the vote</a:t>
             </a:r>
             <a:endParaRPr lang="en-US" sz="1150" dirty="0"/>
           </a:p>
@@ -28694,7 +28694,7 @@
                 <a:ea typeface="Franklin Gothic Demi Cond" pitchFamily="34" charset="-122"/>
                 <a:cs typeface="Franklin Gothic Demi Cond" pitchFamily="34" charset="-120"/>
               </a:rPr>
-              <a:t>88%</a:t>
+              <a:t>88.6%</a:t>
             </a:r>
             <a:endParaRPr lang="en-US" sz="4000" dirty="0"/>
           </a:p>
@@ -29099,7 +29099,7 @@
                 <a:ea typeface="Franklin Gothic Book" pitchFamily="34" charset="-122"/>
                 <a:cs typeface="Franklin Gothic Book" pitchFamily="34" charset="-120"/>
               </a:rPr>
-              <a:t>Measured on hand-labelled government-grid footage, blind to the OCR. 79 of 160 plate crops were unreadable even to a person and are excluded. 78% is below our own 85% target. evidence/ANPR-ACCURACY.md · evidence/CLOCK-READER-ACCURACY.md</a:t>
+              <a:t>Measured on hand-labelled government-grid footage, blind to the OCR. 79 of 160 plate crops were unreadable even to a person and are excluded. 80.5% is below our own 85% target. evidence/ANPR-ACCURACY.md · evidence/CLOCK-READER-ACCURACY.md</a:t>
             </a:r>
             <a:endParaRPr lang="en-US" sz="1000" dirty="0"/>
           </a:p>

</xml_diff>

<commit_message>
Show the report's new map on slide 09, and correct the team's titles
Slide 09 shows a Movement Report re-exported with the street map behind
the route; PITCH_ONLY=report re-exports just the report. On the title
slide Parth is co-founder, and Anuj is an AI engineer with a master's
from Germany; the speaker notes and showcase script say the same.

Co-authored-by: Copilot <223556219+Copilot@users.noreply.github.com>
</commit_message>
<xml_diff>
--- a/docs/Sentinel-Finale-Pitch.pptx
+++ b/docs/Sentinel-Finale-Pitch.pptx
@@ -1072,8 +1072,8 @@
               <a:rPr lang="en-US" dirty="0"/>
               <a:t>[0:00–0:45] Open with the outcome, not the technology.
 “Sentinel lets an officer type a registration number and see where that vehicle went, across the government’s cameras — and be told the moment it is seen again.”
-Then ten seconds on who we are — and do not read the credentials out; the panel has heard every team list theirs. Point at them and say what they mean for this room: “I’m Parth Patel, I lead the team; with me is Anuj Patel. Our backgrounds are on the slide — enterprise AI architecture and data science. What that means for you: every number we show today, we measured, and we will tell you where we fell short.”
-If asked: Parth is a consulting AI solution architect who has worked with IBM and United Airlines, with an MTech in Data Science from IIT Bombay. Anuj is a data scientist based in Göttingen, Germany.
+Then ten seconds on who we are — and do not read the credentials out; the panel has heard every team list theirs. Point at them and say what they mean for this room: “I’m Parth Patel, co-founder of Invental Data Labs; with me is Anuj Patel, our AI engineer. Our backgrounds are on the slide — enterprise AI architecture and AI engineering. What that means for you: every number we show today, we measured, and we will tell you where we fell short.”
+If asked: Parth, co-founder, is an AI solution architect who has worked with IBM and United Airlines, with an MTech in Data Science from IIT Bombay. Anuj is an AI engineer with a master’s degree from Germany.
 The row under the screenshot is a real sighting from the government grid: the plate, the camera, and the time printed on that camera’s own frame.
 If the jury hands over a vehicle number or asks for the live trace now, go straight to slide 04 and come back.</a:t>
             </a:r>
@@ -4211,7 +4211,7 @@
                 <a:ea typeface="Franklin Gothic Book" pitchFamily="34" charset="-122"/>
                 <a:cs typeface="Franklin Gothic Book" pitchFamily="34" charset="-120"/>
               </a:rPr>
-              <a:t>   Team lead · AI solution architect</a:t>
+              <a:t>   Co-founder · AI solution architect</a:t>
             </a:r>
             <a:endParaRPr lang="en-US" sz="1400" dirty="0"/>
           </a:p>
@@ -4545,7 +4545,7 @@
                 <a:ea typeface="Franklin Gothic Book" pitchFamily="34" charset="-122"/>
                 <a:cs typeface="Franklin Gothic Book" pitchFamily="34" charset="-120"/>
               </a:rPr>
-              <a:t>   Data scientist</a:t>
+              <a:t>   AI engineer</a:t>
             </a:r>
             <a:endParaRPr lang="en-US" sz="1400" dirty="0"/>
           </a:p>
@@ -4609,7 +4609,7 @@
                 <a:ea typeface="Consolas" pitchFamily="34" charset="-122"/>
                 <a:cs typeface="Consolas" pitchFamily="34" charset="-120"/>
               </a:rPr>
-              <a:t>Göttingen, Germany</a:t>
+              <a:t>Master’s · Germany</a:t>
             </a:r>
             <a:endParaRPr lang="en-US" sz="1100" dirty="0"/>
           </a:p>
@@ -32129,7 +32129,7 @@
                 <a:ea typeface="Consolas" pitchFamily="34" charset="-122"/>
                 <a:cs typeface="Consolas" pitchFamily="34" charset="-120"/>
               </a:rPr>
-              <a:t>cde7918bc28b314a…</a:t>
+              <a:t>8e85d1829a53be09…</a:t>
             </a:r>
             <a:endParaRPr lang="en-US" sz="1100" dirty="0"/>
           </a:p>
@@ -32207,7 +32207,7 @@
                 <a:ea typeface="Consolas" pitchFamily="34" charset="-122"/>
                 <a:cs typeface="Consolas" pitchFamily="34" charset="-120"/>
               </a:rPr>
-              <a:t>7ef88b707cfd252d…</a:t>
+              <a:t>c2b4e5db7d471d8f…</a:t>
             </a:r>
             <a:endParaRPr lang="en-US" sz="1100" dirty="0"/>
           </a:p>
@@ -32285,7 +32285,7 @@
                 <a:ea typeface="Consolas" pitchFamily="34" charset="-122"/>
                 <a:cs typeface="Consolas" pitchFamily="34" charset="-120"/>
               </a:rPr>
-              <a:t>0616ea25c31de3e7…</a:t>
+              <a:t>ca7661f0d5a25ace…</a:t>
             </a:r>
             <a:endParaRPr lang="en-US" sz="1100" dirty="0"/>
           </a:p>

</xml_diff>